<commit_message>
docs: update the AAKI overview presentation
Binary, 1.21 MB -> 1.39 MB. Committed as part of a working-tree sweep rather than
authored here, so the content is unreviewed; amend if it was mid-edit.

Co-Authored-By: Claude Opus 5 (1M context) <noreply@anthropic.com>
</commit_message>
<xml_diff>
--- a/docs/AAKI-Overview-Presentation.pptx
+++ b/docs/AAKI-Overview-Presentation.pptx
@@ -21,9 +21,10 @@
     <p:sldId id="272" r:id="rId15"/>
     <p:sldId id="273" r:id="rId16"/>
     <p:sldId id="274" r:id="rId17"/>
-    <p:sldId id="278" r:id="rId18"/>
-    <p:sldId id="279" r:id="rId19"/>
-    <p:sldId id="277" r:id="rId20"/>
+    <p:sldId id="280" r:id="rId18"/>
+    <p:sldId id="278" r:id="rId19"/>
+    <p:sldId id="279" r:id="rId20"/>
+    <p:sldId id="277" r:id="rId21"/>
   </p:sldIdLst>
   <p:sldSz cx="9144000" cy="6858000" type="screen4x3"/>
   <p:notesSz cx="6858000" cy="9144000"/>
@@ -320,7 +321,7 @@
           <a:p>
             <a:fld id="{241EB5C9-1307-BA42-ABA2-0BC069CD8E7F}" type="datetimeFigureOut">
               <a:rPr lang="en-US" smtClean="0"/>
-              <a:t>9/4/26</a:t>
+              <a:t>9/18/26</a:t>
             </a:fld>
             <a:endParaRPr lang="en-US"/>
           </a:p>
@@ -488,7 +489,7 @@
           <a:p>
             <a:fld id="{241EB5C9-1307-BA42-ABA2-0BC069CD8E7F}" type="datetimeFigureOut">
               <a:rPr lang="en-US" smtClean="0"/>
-              <a:t>9/4/26</a:t>
+              <a:t>9/18/26</a:t>
             </a:fld>
             <a:endParaRPr lang="en-US"/>
           </a:p>
@@ -666,7 +667,7 @@
           <a:p>
             <a:fld id="{241EB5C9-1307-BA42-ABA2-0BC069CD8E7F}" type="datetimeFigureOut">
               <a:rPr lang="en-US" smtClean="0"/>
-              <a:t>9/4/26</a:t>
+              <a:t>9/18/26</a:t>
             </a:fld>
             <a:endParaRPr lang="en-US"/>
           </a:p>
@@ -834,7 +835,7 @@
           <a:p>
             <a:fld id="{241EB5C9-1307-BA42-ABA2-0BC069CD8E7F}" type="datetimeFigureOut">
               <a:rPr lang="en-US" smtClean="0"/>
-              <a:t>9/4/26</a:t>
+              <a:t>9/18/26</a:t>
             </a:fld>
             <a:endParaRPr lang="en-US"/>
           </a:p>
@@ -1079,7 +1080,7 @@
           <a:p>
             <a:fld id="{241EB5C9-1307-BA42-ABA2-0BC069CD8E7F}" type="datetimeFigureOut">
               <a:rPr lang="en-US" smtClean="0"/>
-              <a:t>9/4/26</a:t>
+              <a:t>9/18/26</a:t>
             </a:fld>
             <a:endParaRPr lang="en-US"/>
           </a:p>
@@ -1364,7 +1365,7 @@
           <a:p>
             <a:fld id="{241EB5C9-1307-BA42-ABA2-0BC069CD8E7F}" type="datetimeFigureOut">
               <a:rPr lang="en-US" smtClean="0"/>
-              <a:t>9/4/26</a:t>
+              <a:t>9/18/26</a:t>
             </a:fld>
             <a:endParaRPr lang="en-US"/>
           </a:p>
@@ -1783,7 +1784,7 @@
           <a:p>
             <a:fld id="{241EB5C9-1307-BA42-ABA2-0BC069CD8E7F}" type="datetimeFigureOut">
               <a:rPr lang="en-US" smtClean="0"/>
-              <a:t>9/4/26</a:t>
+              <a:t>9/18/26</a:t>
             </a:fld>
             <a:endParaRPr lang="en-US"/>
           </a:p>
@@ -1900,7 +1901,7 @@
           <a:p>
             <a:fld id="{241EB5C9-1307-BA42-ABA2-0BC069CD8E7F}" type="datetimeFigureOut">
               <a:rPr lang="en-US" smtClean="0"/>
-              <a:t>9/4/26</a:t>
+              <a:t>9/18/26</a:t>
             </a:fld>
             <a:endParaRPr lang="en-US"/>
           </a:p>
@@ -1995,7 +1996,7 @@
           <a:p>
             <a:fld id="{241EB5C9-1307-BA42-ABA2-0BC069CD8E7F}" type="datetimeFigureOut">
               <a:rPr lang="en-US" smtClean="0"/>
-              <a:t>9/4/26</a:t>
+              <a:t>9/18/26</a:t>
             </a:fld>
             <a:endParaRPr lang="en-US"/>
           </a:p>
@@ -2270,7 +2271,7 @@
           <a:p>
             <a:fld id="{241EB5C9-1307-BA42-ABA2-0BC069CD8E7F}" type="datetimeFigureOut">
               <a:rPr lang="en-US" smtClean="0"/>
-              <a:t>9/4/26</a:t>
+              <a:t>9/18/26</a:t>
             </a:fld>
             <a:endParaRPr lang="en-US"/>
           </a:p>
@@ -2522,7 +2523,7 @@
           <a:p>
             <a:fld id="{241EB5C9-1307-BA42-ABA2-0BC069CD8E7F}" type="datetimeFigureOut">
               <a:rPr lang="en-US" smtClean="0"/>
-              <a:t>9/4/26</a:t>
+              <a:t>9/18/26</a:t>
             </a:fld>
             <a:endParaRPr lang="en-US"/>
           </a:p>
@@ -2733,7 +2734,7 @@
           <a:p>
             <a:fld id="{241EB5C9-1307-BA42-ABA2-0BC069CD8E7F}" type="datetimeFigureOut">
               <a:rPr lang="en-US" smtClean="0"/>
-              <a:t>9/4/26</a:t>
+              <a:t>9/18/26</a:t>
             </a:fld>
             <a:endParaRPr lang="en-US"/>
           </a:p>
@@ -4552,6 +4553,94 @@
           <a:chExt cx="0" cy="0"/>
         </a:xfrm>
       </p:grpSpPr>
+      <p:sp>
+        <p:nvSpPr>
+          <p:cNvPr id="2" name="Title 1">
+            <a:extLst>
+              <a:ext uri="{FF2B5EF4-FFF2-40B4-BE49-F238E27FC236}">
+                <a16:creationId xmlns:a16="http://schemas.microsoft.com/office/drawing/2014/main" id="{455EAB87-0611-A2C6-96FB-5DAA2F9CE73C}"/>
+              </a:ext>
+            </a:extLst>
+          </p:cNvPr>
+          <p:cNvSpPr>
+            <a:spLocks noGrp="1"/>
+          </p:cNvSpPr>
+          <p:nvPr>
+            <p:ph type="title"/>
+          </p:nvPr>
+        </p:nvSpPr>
+        <p:spPr/>
+        <p:txBody>
+          <a:bodyPr/>
+          <a:lstStyle/>
+          <a:p>
+            <a:r>
+              <a:rPr lang="en-US" dirty="0"/>
+              <a:t>BMM Overview</a:t>
+            </a:r>
+          </a:p>
+        </p:txBody>
+      </p:sp>
+      <p:pic>
+        <p:nvPicPr>
+          <p:cNvPr id="3" name="Picture 2">
+            <a:extLst>
+              <a:ext uri="{FF2B5EF4-FFF2-40B4-BE49-F238E27FC236}">
+                <a16:creationId xmlns:a16="http://schemas.microsoft.com/office/drawing/2014/main" id="{47223FE5-8682-9261-5BCA-060760CD2049}"/>
+              </a:ext>
+            </a:extLst>
+          </p:cNvPr>
+          <p:cNvPicPr>
+            <a:picLocks noChangeAspect="1"/>
+          </p:cNvPicPr>
+          <p:nvPr/>
+        </p:nvPicPr>
+        <p:blipFill>
+          <a:blip r:embed="rId2"/>
+          <a:stretch>
+            <a:fillRect/>
+          </a:stretch>
+        </p:blipFill>
+        <p:spPr>
+          <a:xfrm>
+            <a:off x="1376917" y="1221400"/>
+            <a:ext cx="6568890" cy="5636600"/>
+          </a:xfrm>
+          <a:prstGeom prst="rect">
+            <a:avLst/>
+          </a:prstGeom>
+        </p:spPr>
+      </p:pic>
+    </p:spTree>
+    <p:extLst>
+      <p:ext uri="{BB962C8B-B14F-4D97-AF65-F5344CB8AC3E}">
+        <p14:creationId xmlns:p14="http://schemas.microsoft.com/office/powerpoint/2010/main" val="402149987"/>
+      </p:ext>
+    </p:extLst>
+  </p:cSld>
+  <p:clrMapOvr>
+    <a:masterClrMapping/>
+  </p:clrMapOvr>
+</p:sld>
+</file>
+
+<file path=ppt/slides/slide18.xml><?xml version="1.0" encoding="utf-8"?>
+<p:sld xmlns:a="http://schemas.openxmlformats.org/drawingml/2006/main" xmlns:r="http://schemas.openxmlformats.org/officeDocument/2006/relationships" xmlns:p="http://schemas.openxmlformats.org/presentationml/2006/main">
+  <p:cSld>
+    <p:spTree>
+      <p:nvGrpSpPr>
+        <p:cNvPr id="1" name=""/>
+        <p:cNvGrpSpPr/>
+        <p:nvPr/>
+      </p:nvGrpSpPr>
+      <p:grpSpPr>
+        <a:xfrm>
+          <a:off x="0" y="0"/>
+          <a:ext cx="0" cy="0"/>
+          <a:chOff x="0" y="0"/>
+          <a:chExt cx="0" cy="0"/>
+        </a:xfrm>
+      </p:grpSpPr>
       <p:pic>
         <p:nvPicPr>
           <p:cNvPr id="2" name="Picture 1">
@@ -4623,278 +4712,6 @@
 </p:sld>
 </file>
 
-<file path=ppt/slides/slide18.xml><?xml version="1.0" encoding="utf-8"?>
-<p:sld xmlns:a="http://schemas.openxmlformats.org/drawingml/2006/main" xmlns:r="http://schemas.openxmlformats.org/officeDocument/2006/relationships" xmlns:p="http://schemas.openxmlformats.org/presentationml/2006/main">
-  <p:cSld>
-    <p:spTree>
-      <p:nvGrpSpPr>
-        <p:cNvPr id="1" name=""/>
-        <p:cNvGrpSpPr/>
-        <p:nvPr/>
-      </p:nvGrpSpPr>
-      <p:grpSpPr>
-        <a:xfrm>
-          <a:off x="0" y="0"/>
-          <a:ext cx="0" cy="0"/>
-          <a:chOff x="0" y="0"/>
-          <a:chExt cx="0" cy="0"/>
-        </a:xfrm>
-      </p:grpSpPr>
-      <p:sp>
-        <p:nvSpPr>
-          <p:cNvPr id="2" name="Title 1">
-            <a:extLst>
-              <a:ext uri="{FF2B5EF4-FFF2-40B4-BE49-F238E27FC236}">
-                <a16:creationId xmlns:a16="http://schemas.microsoft.com/office/drawing/2014/main" id="{A45D370F-9289-17BD-64CC-4AA09D7887DE}"/>
-              </a:ext>
-            </a:extLst>
-          </p:cNvPr>
-          <p:cNvSpPr>
-            <a:spLocks noGrp="1"/>
-          </p:cNvSpPr>
-          <p:nvPr>
-            <p:ph type="title"/>
-          </p:nvPr>
-        </p:nvSpPr>
-        <p:spPr/>
-        <p:txBody>
-          <a:bodyPr>
-            <a:normAutofit/>
-          </a:bodyPr>
-          <a:lstStyle/>
-          <a:p>
-            <a:pPr algn="l"/>
-            <a:r>
-              <a:rPr lang="en-US" sz="2000" dirty="0"/>
-              <a:t>Prompt: Identify Goals on the EU-Rent </a:t>
-            </a:r>
-            <a:r>
-              <a:rPr lang="en-US" sz="2000" dirty="0" err="1"/>
-              <a:t>ServiceProvider</a:t>
-            </a:r>
-            <a:r>
-              <a:rPr lang="en-US" sz="2000" dirty="0"/>
-              <a:t> that have no realizing</a:t>
-            </a:r>
-            <a:br>
-              <a:rPr lang="en-US" sz="2000" dirty="0"/>
-            </a:br>
-            <a:r>
-              <a:rPr lang="en-US" sz="2000" dirty="0"/>
-              <a:t>Tactic chain</a:t>
-            </a:r>
-          </a:p>
-        </p:txBody>
-      </p:sp>
-      <p:sp>
-        <p:nvSpPr>
-          <p:cNvPr id="3" name="Content Placeholder 2">
-            <a:extLst>
-              <a:ext uri="{FF2B5EF4-FFF2-40B4-BE49-F238E27FC236}">
-                <a16:creationId xmlns:a16="http://schemas.microsoft.com/office/drawing/2014/main" id="{98D09A78-69C9-5709-71F7-9A37AFD6D504}"/>
-              </a:ext>
-            </a:extLst>
-          </p:cNvPr>
-          <p:cNvSpPr>
-            <a:spLocks noGrp="1"/>
-          </p:cNvSpPr>
-          <p:nvPr>
-            <p:ph idx="1"/>
-          </p:nvPr>
-        </p:nvSpPr>
-        <p:spPr/>
-        <p:txBody>
-          <a:bodyPr>
-            <a:normAutofit fontScale="77500" lnSpcReduction="20000"/>
-          </a:bodyPr>
-          <a:lstStyle/>
-          <a:p>
-            <a:pPr marL="0" indent="0">
-              <a:buNone/>
-            </a:pPr>
-            <a:r>
-              <a:rPr lang="en-US" dirty="0"/>
-              <a:t>Result:</a:t>
-            </a:r>
-          </a:p>
-          <a:p>
-            <a:pPr marL="0" indent="0">
-              <a:buNone/>
-            </a:pPr>
-            <a:endParaRPr lang="en-US" dirty="0"/>
-          </a:p>
-          <a:p>
-            <a:pPr marL="0" indent="0">
-              <a:buNone/>
-            </a:pPr>
-            <a:r>
-              <a:rPr lang="en-US" dirty="0"/>
-              <a:t>Traced </a:t>
-            </a:r>
-            <a:r>
-              <a:rPr lang="en-US" b="1" dirty="0"/>
-              <a:t>Goal ← </a:t>
-            </a:r>
-            <a:r>
-              <a:rPr lang="en-US" b="1" dirty="0" err="1"/>
-              <a:t>channelsEffortsToward</a:t>
-            </a:r>
-            <a:r>
-              <a:rPr lang="en-US" b="1" dirty="0"/>
-              <a:t> — Strategy ← implements — Tactic</a:t>
-            </a:r>
-            <a:r>
-              <a:rPr lang="en-US" dirty="0"/>
-              <a:t> across the 4 EU-Rent Goals. One is fully realized; three have broken chains:</a:t>
-            </a:r>
-          </a:p>
-          <a:p>
-            <a:r>
-              <a:rPr lang="en-US" b="1" dirty="0"/>
-              <a:t>Fully covered:</a:t>
-            </a:r>
-            <a:r>
-              <a:rPr lang="en-US" dirty="0"/>
-              <a:t> </a:t>
-            </a:r>
-            <a:r>
-              <a:rPr lang="en-US" i="1" dirty="0"/>
-              <a:t>Provide well-maintained cars</a:t>
-            </a:r>
-            <a:r>
-              <a:rPr lang="en-US" dirty="0"/>
-              <a:t> (…/goal-well-maintained-cars) — two Strategies, both implemented by Tactics.</a:t>
-            </a:r>
-          </a:p>
-          <a:p>
-            <a:r>
-              <a:rPr lang="en-US" b="1" dirty="0"/>
-              <a:t>Gap, no Means at all:</a:t>
-            </a:r>
-            <a:r>
-              <a:rPr lang="en-US" dirty="0"/>
-              <a:t> </a:t>
-            </a:r>
-            <a:r>
-              <a:rPr lang="en-US" i="1" dirty="0"/>
-              <a:t>Provide industry-leading customer service</a:t>
-            </a:r>
-            <a:r>
-              <a:rPr lang="en-US" dirty="0"/>
-              <a:t> (…/goal-customer-service) — no Strategy channels toward it; only an Objective (85% CSAT) exists. Needs a new Strategy </a:t>
-            </a:r>
-            <a:r>
-              <a:rPr lang="en-US" i="1" dirty="0"/>
-              <a:t>plus</a:t>
-            </a:r>
-            <a:r>
-              <a:rPr lang="en-US" dirty="0"/>
-              <a:t> Tactics (staff training/service standards, complaint resolution, self-service).</a:t>
-            </a:r>
-          </a:p>
-          <a:p>
-            <a:r>
-              <a:rPr lang="en-US" b="1" dirty="0"/>
-              <a:t>Gap, Tactic layer missing:</a:t>
-            </a:r>
-            <a:r>
-              <a:rPr lang="en-US" dirty="0"/>
-              <a:t> </a:t>
-            </a:r>
-            <a:r>
-              <a:rPr lang="en-US" i="1" dirty="0"/>
-              <a:t>Be a premium brand car rental company</a:t>
-            </a:r>
-            <a:r>
-              <a:rPr lang="en-US" dirty="0"/>
-              <a:t> (…/goal-premium-brand) — </a:t>
-            </a:r>
-            <a:r>
-              <a:rPr lang="en-US" dirty="0" err="1"/>
-              <a:t>strat-onairport</a:t>
-            </a:r>
-            <a:r>
-              <a:rPr lang="en-US" dirty="0"/>
-              <a:t> channels toward it but no Tactic implements it. Needs airport-presence execution tactics.</a:t>
-            </a:r>
-          </a:p>
-          <a:p>
-            <a:r>
-              <a:rPr lang="en-US" b="1" dirty="0"/>
-              <a:t>Gap, Tactic layer missing:</a:t>
-            </a:r>
-            <a:r>
-              <a:rPr lang="en-US" dirty="0"/>
-              <a:t> </a:t>
-            </a:r>
-            <a:r>
-              <a:rPr lang="en-US" i="1" dirty="0"/>
-              <a:t>Have vehicles available when and where expected</a:t>
-            </a:r>
-            <a:r>
-              <a:rPr lang="en-US" dirty="0"/>
-              <a:t> (…/goal-vehicle-availability) — </a:t>
-            </a:r>
-            <a:r>
-              <a:rPr lang="en-US" dirty="0" err="1"/>
-              <a:t>strat</a:t>
-            </a:r>
-            <a:r>
-              <a:rPr lang="en-US" dirty="0"/>
-              <a:t>-vehicle-stock channels toward it but no Tactic implements it (and no Objective quantifies it). Needs stock/fleet-balancing tactics.</a:t>
-            </a:r>
-          </a:p>
-          <a:p>
-            <a:pPr marL="0" indent="0">
-              <a:buNone/>
-            </a:pPr>
-            <a:r>
-              <a:rPr lang="en-US" dirty="0"/>
-              <a:t>Root cause: three Strategies (</a:t>
-            </a:r>
-            <a:r>
-              <a:rPr lang="en-US" dirty="0" err="1"/>
-              <a:t>strat-onairport</a:t>
-            </a:r>
-            <a:r>
-              <a:rPr lang="en-US" dirty="0"/>
-              <a:t>, </a:t>
-            </a:r>
-            <a:r>
-              <a:rPr lang="en-US" dirty="0" err="1"/>
-              <a:t>strat</a:t>
-            </a:r>
-            <a:r>
-              <a:rPr lang="en-US" dirty="0"/>
-              <a:t>-vehicle-stock, </a:t>
-            </a:r>
-            <a:r>
-              <a:rPr lang="en-US" dirty="0" err="1"/>
-              <a:t>strat</a:t>
-            </a:r>
-            <a:r>
-              <a:rPr lang="en-US" dirty="0"/>
-              <a:t>-rewards-scheme) have zero implementing Tactics. Also one orphan: tactic-encourage-extensions implements no Strategy. All read-only — nothing changed.</a:t>
-            </a:r>
-          </a:p>
-          <a:p>
-            <a:endParaRPr lang="en-US" dirty="0"/>
-          </a:p>
-        </p:txBody>
-      </p:sp>
-    </p:spTree>
-    <p:extLst>
-      <p:ext uri="{BB962C8B-B14F-4D97-AF65-F5344CB8AC3E}">
-        <p14:creationId xmlns:p14="http://schemas.microsoft.com/office/powerpoint/2010/main" val="2273079731"/>
-      </p:ext>
-    </p:extLst>
-  </p:cSld>
-  <p:clrMapOvr>
-    <a:masterClrMapping/>
-  </p:clrMapOvr>
-</p:sld>
-</file>
-
 <file path=ppt/slides/slide19.xml><?xml version="1.0" encoding="utf-8"?>
 <p:sld xmlns:a="http://schemas.openxmlformats.org/drawingml/2006/main" xmlns:r="http://schemas.openxmlformats.org/officeDocument/2006/relationships" xmlns:p="http://schemas.openxmlformats.org/presentationml/2006/main">
   <p:cSld>
@@ -4914,7 +4731,13 @@
       </p:grpSpPr>
       <p:sp>
         <p:nvSpPr>
-          <p:cNvPr id="2" name="Title 1"/>
+          <p:cNvPr id="2" name="Title 1">
+            <a:extLst>
+              <a:ext uri="{FF2B5EF4-FFF2-40B4-BE49-F238E27FC236}">
+                <a16:creationId xmlns:a16="http://schemas.microsoft.com/office/drawing/2014/main" id="{A45D370F-9289-17BD-64CC-4AA09D7887DE}"/>
+              </a:ext>
+            </a:extLst>
+          </p:cNvPr>
           <p:cNvSpPr>
             <a:spLocks noGrp="1"/>
           </p:cNvSpPr>
@@ -4924,56 +4747,236 @@
         </p:nvSpPr>
         <p:spPr/>
         <p:txBody>
-          <a:bodyPr/>
-          <a:lstStyle/>
-          <a:p>
-            <a:pPr marL="0" lvl="0" indent="0">
+          <a:bodyPr>
+            <a:normAutofit/>
+          </a:bodyPr>
+          <a:lstStyle/>
+          <a:p>
+            <a:pPr algn="l"/>
+            <a:r>
+              <a:rPr lang="en-US" sz="2000" dirty="0"/>
+              <a:t>Prompt: Identify Goals on the EU-Rent </a:t>
+            </a:r>
+            <a:r>
+              <a:rPr lang="en-US" sz="2000" dirty="0" err="1"/>
+              <a:t>ServiceProvider</a:t>
+            </a:r>
+            <a:r>
+              <a:rPr lang="en-US" sz="2000" dirty="0"/>
+              <a:t> that have no realizing</a:t>
+            </a:r>
+            <a:br>
+              <a:rPr lang="en-US" sz="2000" dirty="0"/>
+            </a:br>
+            <a:r>
+              <a:rPr lang="en-US" sz="2000" dirty="0"/>
+              <a:t>Tactic chain</a:t>
+            </a:r>
+          </a:p>
+        </p:txBody>
+      </p:sp>
+      <p:sp>
+        <p:nvSpPr>
+          <p:cNvPr id="3" name="Content Placeholder 2">
+            <a:extLst>
+              <a:ext uri="{FF2B5EF4-FFF2-40B4-BE49-F238E27FC236}">
+                <a16:creationId xmlns:a16="http://schemas.microsoft.com/office/drawing/2014/main" id="{98D09A78-69C9-5709-71F7-9A37AFD6D504}"/>
+              </a:ext>
+            </a:extLst>
+          </p:cNvPr>
+          <p:cNvSpPr>
+            <a:spLocks noGrp="1"/>
+          </p:cNvSpPr>
+          <p:nvPr>
+            <p:ph idx="1"/>
+          </p:nvPr>
+        </p:nvSpPr>
+        <p:spPr/>
+        <p:txBody>
+          <a:bodyPr>
+            <a:normAutofit fontScale="77500" lnSpcReduction="20000"/>
+          </a:bodyPr>
+          <a:lstStyle/>
+          <a:p>
+            <a:pPr marL="0" indent="0">
               <a:buNone/>
             </a:pPr>
             <a:r>
-              <a:t>Thank you</a:t>
-            </a:r>
-          </a:p>
-        </p:txBody>
-      </p:sp>
-      <p:sp>
-        <p:nvSpPr>
-          <p:cNvPr id="3" name="Content Placeholder 2"/>
-          <p:cNvSpPr>
-            <a:spLocks noGrp="1"/>
-          </p:cNvSpPr>
-          <p:nvPr>
-            <p:ph idx="1"/>
-          </p:nvPr>
-        </p:nvSpPr>
-        <p:spPr/>
-        <p:txBody>
-          <a:bodyPr/>
-          <a:lstStyle/>
-          <a:p>
-            <a:pPr marL="0" lvl="0" indent="0">
-              <a:spcBef>
-                <a:spcPts val="3000"/>
-              </a:spcBef>
+              <a:rPr lang="en-US" dirty="0"/>
+              <a:t>Result:</a:t>
+            </a:r>
+          </a:p>
+          <a:p>
+            <a:pPr marL="0" indent="0">
               <a:buNone/>
             </a:pPr>
-            <a:r>
-              <a:rPr b="1"/>
-              <a:t>Questions before the demo?</a:t>
-            </a:r>
-          </a:p>
-          <a:p>
-            <a:pPr marL="1270000" lvl="0" indent="0">
+            <a:endParaRPr lang="en-US" dirty="0"/>
+          </a:p>
+          <a:p>
+            <a:pPr marL="0" indent="0">
               <a:buNone/>
             </a:pPr>
             <a:r>
-              <a:rPr sz="2000" i="1"/>
-              <a:t>The digital thread’s promise was traceability; its unmet need was action. AAKI closes the missing links and missing nodes with AI + OSLC — so the thread becomes something you act on, prove continuously, and improve.</a:t>
-            </a:r>
+              <a:rPr lang="en-US" dirty="0"/>
+              <a:t>Traced </a:t>
+            </a:r>
+            <a:r>
+              <a:rPr lang="en-US" b="1" dirty="0"/>
+              <a:t>Goal ← </a:t>
+            </a:r>
+            <a:r>
+              <a:rPr lang="en-US" b="1" dirty="0" err="1"/>
+              <a:t>channelsEffortsToward</a:t>
+            </a:r>
+            <a:r>
+              <a:rPr lang="en-US" b="1" dirty="0"/>
+              <a:t> — Strategy ← implements — Tactic</a:t>
+            </a:r>
+            <a:r>
+              <a:rPr lang="en-US" dirty="0"/>
+              <a:t> across the 4 EU-Rent Goals. One is fully realized; three have broken chains:</a:t>
+            </a:r>
+          </a:p>
+          <a:p>
+            <a:r>
+              <a:rPr lang="en-US" b="1" dirty="0"/>
+              <a:t>Fully covered:</a:t>
+            </a:r>
+            <a:r>
+              <a:rPr lang="en-US" dirty="0"/>
+              <a:t> </a:t>
+            </a:r>
+            <a:r>
+              <a:rPr lang="en-US" i="1" dirty="0"/>
+              <a:t>Provide well-maintained cars</a:t>
+            </a:r>
+            <a:r>
+              <a:rPr lang="en-US" dirty="0"/>
+              <a:t> (…/goal-well-maintained-cars) — two Strategies, both implemented by Tactics.</a:t>
+            </a:r>
+          </a:p>
+          <a:p>
+            <a:r>
+              <a:rPr lang="en-US" b="1" dirty="0"/>
+              <a:t>Gap, no Means at all:</a:t>
+            </a:r>
+            <a:r>
+              <a:rPr lang="en-US" dirty="0"/>
+              <a:t> </a:t>
+            </a:r>
+            <a:r>
+              <a:rPr lang="en-US" i="1" dirty="0"/>
+              <a:t>Provide industry-leading customer service</a:t>
+            </a:r>
+            <a:r>
+              <a:rPr lang="en-US" dirty="0"/>
+              <a:t> (…/goal-customer-service) — no Strategy channels toward it; only an Objective (85% CSAT) exists. Needs a new Strategy </a:t>
+            </a:r>
+            <a:r>
+              <a:rPr lang="en-US" i="1" dirty="0"/>
+              <a:t>plus</a:t>
+            </a:r>
+            <a:r>
+              <a:rPr lang="en-US" dirty="0"/>
+              <a:t> Tactics (staff training/service standards, complaint resolution, self-service).</a:t>
+            </a:r>
+          </a:p>
+          <a:p>
+            <a:r>
+              <a:rPr lang="en-US" b="1" dirty="0"/>
+              <a:t>Gap, Tactic layer missing:</a:t>
+            </a:r>
+            <a:r>
+              <a:rPr lang="en-US" dirty="0"/>
+              <a:t> </a:t>
+            </a:r>
+            <a:r>
+              <a:rPr lang="en-US" i="1" dirty="0"/>
+              <a:t>Be a premium brand car rental company</a:t>
+            </a:r>
+            <a:r>
+              <a:rPr lang="en-US" dirty="0"/>
+              <a:t> (…/goal-premium-brand) — </a:t>
+            </a:r>
+            <a:r>
+              <a:rPr lang="en-US" dirty="0" err="1"/>
+              <a:t>strat-onairport</a:t>
+            </a:r>
+            <a:r>
+              <a:rPr lang="en-US" dirty="0"/>
+              <a:t> channels toward it but no Tactic implements it. Needs airport-presence execution tactics.</a:t>
+            </a:r>
+          </a:p>
+          <a:p>
+            <a:r>
+              <a:rPr lang="en-US" b="1" dirty="0"/>
+              <a:t>Gap, Tactic layer missing:</a:t>
+            </a:r>
+            <a:r>
+              <a:rPr lang="en-US" dirty="0"/>
+              <a:t> </a:t>
+            </a:r>
+            <a:r>
+              <a:rPr lang="en-US" i="1" dirty="0"/>
+              <a:t>Have vehicles available when and where expected</a:t>
+            </a:r>
+            <a:r>
+              <a:rPr lang="en-US" dirty="0"/>
+              <a:t> (…/goal-vehicle-availability) — </a:t>
+            </a:r>
+            <a:r>
+              <a:rPr lang="en-US" dirty="0" err="1"/>
+              <a:t>strat</a:t>
+            </a:r>
+            <a:r>
+              <a:rPr lang="en-US" dirty="0"/>
+              <a:t>-vehicle-stock channels toward it but no Tactic implements it (and no Objective quantifies it). Needs stock/fleet-balancing tactics.</a:t>
+            </a:r>
+          </a:p>
+          <a:p>
+            <a:pPr marL="0" indent="0">
+              <a:buNone/>
+            </a:pPr>
+            <a:r>
+              <a:rPr lang="en-US" dirty="0"/>
+              <a:t>Root cause: three Strategies (</a:t>
+            </a:r>
+            <a:r>
+              <a:rPr lang="en-US" dirty="0" err="1"/>
+              <a:t>strat-onairport</a:t>
+            </a:r>
+            <a:r>
+              <a:rPr lang="en-US" dirty="0"/>
+              <a:t>, </a:t>
+            </a:r>
+            <a:r>
+              <a:rPr lang="en-US" dirty="0" err="1"/>
+              <a:t>strat</a:t>
+            </a:r>
+            <a:r>
+              <a:rPr lang="en-US" dirty="0"/>
+              <a:t>-vehicle-stock, </a:t>
+            </a:r>
+            <a:r>
+              <a:rPr lang="en-US" dirty="0" err="1"/>
+              <a:t>strat</a:t>
+            </a:r>
+            <a:r>
+              <a:rPr lang="en-US" dirty="0"/>
+              <a:t>-rewards-scheme) have zero implementing Tactics. Also one orphan: tactic-encourage-extensions implements no Strategy. All read-only — nothing changed.</a:t>
+            </a:r>
+          </a:p>
+          <a:p>
+            <a:endParaRPr lang="en-US" dirty="0"/>
           </a:p>
         </p:txBody>
       </p:sp>
     </p:spTree>
+    <p:extLst>
+      <p:ext uri="{BB962C8B-B14F-4D97-AF65-F5344CB8AC3E}">
+        <p14:creationId xmlns:p14="http://schemas.microsoft.com/office/powerpoint/2010/main" val="2273079731"/>
+      </p:ext>
+    </p:extLst>
   </p:cSld>
   <p:clrMapOvr>
     <a:masterClrMapping/>
@@ -5140,6 +5143,92 @@
 </p:sld>
 </file>
 
+<file path=ppt/slides/slide20.xml><?xml version="1.0" encoding="utf-8"?>
+<p:sld xmlns:a="http://schemas.openxmlformats.org/drawingml/2006/main" xmlns:r="http://schemas.openxmlformats.org/officeDocument/2006/relationships" xmlns:p="http://schemas.openxmlformats.org/presentationml/2006/main">
+  <p:cSld>
+    <p:spTree>
+      <p:nvGrpSpPr>
+        <p:cNvPr id="1" name=""/>
+        <p:cNvGrpSpPr/>
+        <p:nvPr/>
+      </p:nvGrpSpPr>
+      <p:grpSpPr>
+        <a:xfrm>
+          <a:off x="0" y="0"/>
+          <a:ext cx="0" cy="0"/>
+          <a:chOff x="0" y="0"/>
+          <a:chExt cx="0" cy="0"/>
+        </a:xfrm>
+      </p:grpSpPr>
+      <p:sp>
+        <p:nvSpPr>
+          <p:cNvPr id="2" name="Title 1"/>
+          <p:cNvSpPr>
+            <a:spLocks noGrp="1"/>
+          </p:cNvSpPr>
+          <p:nvPr>
+            <p:ph type="title"/>
+          </p:nvPr>
+        </p:nvSpPr>
+        <p:spPr/>
+        <p:txBody>
+          <a:bodyPr/>
+          <a:lstStyle/>
+          <a:p>
+            <a:pPr marL="0" lvl="0" indent="0">
+              <a:buNone/>
+            </a:pPr>
+            <a:r>
+              <a:t>Thank you</a:t>
+            </a:r>
+          </a:p>
+        </p:txBody>
+      </p:sp>
+      <p:sp>
+        <p:nvSpPr>
+          <p:cNvPr id="3" name="Content Placeholder 2"/>
+          <p:cNvSpPr>
+            <a:spLocks noGrp="1"/>
+          </p:cNvSpPr>
+          <p:nvPr>
+            <p:ph idx="1"/>
+          </p:nvPr>
+        </p:nvSpPr>
+        <p:spPr/>
+        <p:txBody>
+          <a:bodyPr/>
+          <a:lstStyle/>
+          <a:p>
+            <a:pPr marL="0" lvl="0" indent="0">
+              <a:spcBef>
+                <a:spcPts val="3000"/>
+              </a:spcBef>
+              <a:buNone/>
+            </a:pPr>
+            <a:r>
+              <a:rPr b="1"/>
+              <a:t>Questions before the demo?</a:t>
+            </a:r>
+          </a:p>
+          <a:p>
+            <a:pPr marL="1270000" lvl="0" indent="0">
+              <a:buNone/>
+            </a:pPr>
+            <a:r>
+              <a:rPr sz="2000" i="1"/>
+              <a:t>The digital thread’s promise was traceability; its unmet need was action. AAKI closes the missing links and missing nodes with AI + OSLC — so the thread becomes something you act on, prove continuously, and improve.</a:t>
+            </a:r>
+          </a:p>
+        </p:txBody>
+      </p:sp>
+    </p:spTree>
+  </p:cSld>
+  <p:clrMapOvr>
+    <a:masterClrMapping/>
+  </p:clrMapOvr>
+</p:sld>
+</file>
+
 <file path=ppt/slides/slide3.xml><?xml version="1.0" encoding="utf-8"?>
 <p:sld xmlns:a="http://schemas.openxmlformats.org/drawingml/2006/main" xmlns:r="http://schemas.openxmlformats.org/officeDocument/2006/relationships" xmlns:p="http://schemas.openxmlformats.org/presentationml/2006/main">
   <p:cSld>
@@ -5608,6 +5697,7 @@
               <a:buNone/>
             </a:pPr>
             <a:r>
+              <a:rPr dirty="0"/>
               <a:t>The four “what ifs” are the four AAKI stages</a:t>
             </a:r>
           </a:p>

</xml_diff>